<commit_message>
Add live deployment links to the final deck (slides 2 and 7).
Both MVP ("TieBreaker") and review-analysis-agent (discovery console)
buttons now link to their real Streamlit Community Cloud URLs, verified
live (both open without sign-in and show the current deployed app -- dark
sidebar, TieBreaker branding, real photos on the MVP; 8-page button nav on
the discovery console). Restyled from the amber "pending" look to a solid
teal button now that the links are real.

Co-Authored-By: Claude Sonnet 5 <noreply@anthropic.com>
</commit_message>
<xml_diff>
--- a/reports/final_deck.pptx
+++ b/reports/final_deck.pptx
@@ -6029,19 +6029,16 @@
             </a:avLst>
           </a:prstGeom>
           <a:solidFill>
-            <a:srgbClr val="F6E7D2"/>
+            <a:srgbClr val="0F766E"/>
           </a:solidFill>
-          <a:ln w="15875">
-            <a:solidFill>
-              <a:srgbClr val="B45309"/>
-            </a:solidFill>
-            <a:prstDash val="solid"/>
-          </a:ln>
-        </p:spPr>
-      </p:sp>
-      <p:sp>
-        <p:nvSpPr>
-          <p:cNvPr id="38" name="Text 30"/>
+          <a:ln/>
+        </p:spPr>
+      </p:sp>
+      <p:sp>
+        <p:nvSpPr>
+          <p:cNvPr id="38" name="Text 30">
+            <a:hlinkClick r:id="rId7" tooltip=""/>
+          </p:cNvPr>
           <p:cNvSpPr txBox="1"/>
           <p:nvPr/>
         </p:nvSpPr>
@@ -6064,15 +6061,22 @@
               <a:buNone/>
             </a:pPr>
             <a:r>
-              <a:rPr lang="en-US" sz="1500" b="1" dirty="0">
-                <a:solidFill>
-                  <a:srgbClr val="B45309"/>
+              <a:rPr lang="en-US" sz="1500" b="1" u="sng" dirty="0">
+                <a:solidFill>
+                  <a:srgbClr val="FFFFFF"/>
                 </a:solidFill>
                 <a:latin typeface="Calibri" pitchFamily="34" charset="0"/>
                 <a:ea typeface="Calibri" pitchFamily="34" charset="-122"/>
                 <a:cs typeface="Calibri" pitchFamily="34" charset="-120"/>
-              </a:rPr>
-              <a:t>Live MVP (“TieBreaker”)  →  link to be added</a:t>
+                <a:hlinkClick r:id="rId7" invalidUrl="" action="" tgtFrame="" tooltip="" history="1" highlightClick="0" endSnd="0">
+                  <a:extLst>
+                    <a:ext uri="{A12FA001-AC4F-418D-AE19-62706E023703}">
+                      <ahyp:hlinkClr xmlns:ahyp="http://schemas.microsoft.com/office/drawing/2018/hyperlinkcolor" val="tx"/>
+                    </a:ext>
+                  </a:extLst>
+                </a:hlinkClick>
+              </a:rPr>
+              <a:t>Live MVP (“TieBreaker”)  →  open ↗</a:t>
             </a:r>
             <a:endParaRPr lang="en-US" sz="1500" dirty="0"/>
           </a:p>
@@ -6095,19 +6099,16 @@
             </a:avLst>
           </a:prstGeom>
           <a:solidFill>
-            <a:srgbClr val="F6E7D2"/>
+            <a:srgbClr val="0F766E"/>
           </a:solidFill>
-          <a:ln w="15875">
-            <a:solidFill>
-              <a:srgbClr val="B45309"/>
-            </a:solidFill>
-            <a:prstDash val="solid"/>
-          </a:ln>
-        </p:spPr>
-      </p:sp>
-      <p:sp>
-        <p:nvSpPr>
-          <p:cNvPr id="40" name="Text 32"/>
+          <a:ln/>
+        </p:spPr>
+      </p:sp>
+      <p:sp>
+        <p:nvSpPr>
+          <p:cNvPr id="40" name="Text 32">
+            <a:hlinkClick r:id="rId8" tooltip=""/>
+          </p:cNvPr>
           <p:cNvSpPr txBox="1"/>
           <p:nvPr/>
         </p:nvSpPr>
@@ -6130,15 +6131,22 @@
               <a:buNone/>
             </a:pPr>
             <a:r>
-              <a:rPr lang="en-US" sz="1500" b="1" dirty="0">
-                <a:solidFill>
-                  <a:srgbClr val="B45309"/>
+              <a:rPr lang="en-US" sz="1500" b="1" u="sng" dirty="0">
+                <a:solidFill>
+                  <a:srgbClr val="FFFFFF"/>
                 </a:solidFill>
                 <a:latin typeface="Calibri" pitchFamily="34" charset="0"/>
                 <a:ea typeface="Calibri" pitchFamily="34" charset="-122"/>
                 <a:cs typeface="Calibri" pitchFamily="34" charset="-120"/>
-              </a:rPr>
-              <a:t>Live Review Analysis Agent  →  link to be added</a:t>
+                <a:hlinkClick r:id="rId8" invalidUrl="" action="" tgtFrame="" tooltip="" history="1" highlightClick="0" endSnd="0">
+                  <a:extLst>
+                    <a:ext uri="{A12FA001-AC4F-418D-AE19-62706E023703}">
+                      <ahyp:hlinkClr xmlns:ahyp="http://schemas.microsoft.com/office/drawing/2018/hyperlinkcolor" val="tx"/>
+                    </a:ext>
+                  </a:extLst>
+                </a:hlinkClick>
+              </a:rPr>
+              <a:t>Live Review Analysis Agent  →  open ↗</a:t>
             </a:r>
             <a:endParaRPr lang="en-US" sz="1500" dirty="0"/>
           </a:p>
@@ -6147,7 +6155,7 @@
       <p:sp>
         <p:nvSpPr>
           <p:cNvPr id="41" name="Text 33">
-            <a:hlinkClick r:id="rId7" tooltip=""/>
+            <a:hlinkClick r:id="rId9" tooltip=""/>
           </p:cNvPr>
           <p:cNvSpPr txBox="1"/>
           <p:nvPr/>
@@ -6178,7 +6186,7 @@
                 <a:latin typeface="Calibri" pitchFamily="34" charset="0"/>
                 <a:ea typeface="Calibri" pitchFamily="34" charset="-122"/>
                 <a:cs typeface="Calibri" pitchFamily="34" charset="-120"/>
-                <a:hlinkClick r:id="rId7" invalidUrl="" action="" tgtFrame="" tooltip="" history="1" highlightClick="0" endSnd="0">
+                <a:hlinkClick r:id="rId9" invalidUrl="" action="" tgtFrame="" tooltip="" history="1" highlightClick="0" endSnd="0">
                   <a:extLst>
                     <a:ext uri="{A12FA001-AC4F-418D-AE19-62706E023703}">
                       <ahyp:hlinkClr xmlns:ahyp="http://schemas.microsoft.com/office/drawing/2018/hyperlinkcolor" val="tx"/>
@@ -15596,19 +15604,16 @@
             </a:avLst>
           </a:prstGeom>
           <a:solidFill>
-            <a:srgbClr val="F6E7D2"/>
+            <a:srgbClr val="0F766E"/>
           </a:solidFill>
-          <a:ln w="15875">
-            <a:solidFill>
-              <a:srgbClr val="B45309"/>
-            </a:solidFill>
-            <a:prstDash val="solid"/>
-          </a:ln>
-        </p:spPr>
-      </p:sp>
-      <p:sp>
-        <p:nvSpPr>
-          <p:cNvPr id="43" name="Text 29"/>
+          <a:ln/>
+        </p:spPr>
+      </p:sp>
+      <p:sp>
+        <p:nvSpPr>
+          <p:cNvPr id="43" name="Text 29">
+            <a:hlinkClick r:id="rId13" tooltip=""/>
+          </p:cNvPr>
           <p:cNvSpPr txBox="1"/>
           <p:nvPr/>
         </p:nvSpPr>
@@ -15631,15 +15636,22 @@
               <a:buNone/>
             </a:pPr>
             <a:r>
-              <a:rPr lang="en-US" sz="1400" b="1" dirty="0">
-                <a:solidFill>
-                  <a:srgbClr val="B45309"/>
+              <a:rPr lang="en-US" sz="1400" b="1" u="sng" dirty="0">
+                <a:solidFill>
+                  <a:srgbClr val="FFFFFF"/>
                 </a:solidFill>
                 <a:latin typeface="Calibri" pitchFamily="34" charset="0"/>
                 <a:ea typeface="Calibri" pitchFamily="34" charset="-122"/>
                 <a:cs typeface="Calibri" pitchFamily="34" charset="-120"/>
-              </a:rPr>
-              <a:t>Live MVP (“TieBreaker”)  →  link to be added</a:t>
+                <a:hlinkClick r:id="rId13" invalidUrl="" action="" tgtFrame="" tooltip="" history="1" highlightClick="0" endSnd="0">
+                  <a:extLst>
+                    <a:ext uri="{A12FA001-AC4F-418D-AE19-62706E023703}">
+                      <ahyp:hlinkClr xmlns:ahyp="http://schemas.microsoft.com/office/drawing/2018/hyperlinkcolor" val="tx"/>
+                    </a:ext>
+                  </a:extLst>
+                </a:hlinkClick>
+              </a:rPr>
+              <a:t>Live MVP (“TieBreaker”)  →  open ↗</a:t>
             </a:r>
             <a:endParaRPr lang="en-US" sz="1400" dirty="0"/>
           </a:p>

</xml_diff>

<commit_message>
Fix three sub-14pt font-size violations in the final deck.
Submission guidelines require a strict 14pt minimum. An audit found three
places still at 13pt: slide 1's TAM/SAM/SOM tag labels, slide 6's rejected-
alternative chip headings, and slide 9's primary-metric formula text.
Bumped all three to the MIN_PT constant and re-rendered to confirm no
layout regressions (chip heading box grew slightly to fit the larger text
without touching the body text below it).

Also audited and confirmed compliant: 10 slides, every title states an
insight rather than a generic label, no font size below 14pt anywhere
else, file size (754KB, well under 40MB), and both the GitHub repo (Public)
and the survey Google Sheet (view-only, no sign-in required) are genuinely
accessible to an outside reader -- verified by visiting both unauthenticated.

Co-Authored-By: Claude Sonnet 5 <noreply@anthropic.com>
</commit_message>
<xml_diff>
--- a/reports/final_deck.pptx
+++ b/reports/final_deck.pptx
@@ -2172,7 +2172,7 @@
               <a:buNone/>
             </a:pPr>
             <a:r>
-              <a:rPr lang="en-US" sz="1300" b="1" dirty="0">
+              <a:rPr lang="en-US" sz="1400" b="1" dirty="0">
                 <a:solidFill>
                   <a:srgbClr val="AFC0DE"/>
                 </a:solidFill>
@@ -2196,7 +2196,7 @@
               </a:rPr>
               <a:t>$21B</a:t>
             </a:r>
-            <a:endParaRPr lang="en-US" sz="1300" dirty="0"/>
+            <a:endParaRPr lang="en-US" sz="1400" dirty="0"/>
           </a:p>
         </p:txBody>
       </p:sp>
@@ -2306,7 +2306,7 @@
               <a:buNone/>
             </a:pPr>
             <a:r>
-              <a:rPr lang="en-US" sz="1300" b="1" dirty="0">
+              <a:rPr lang="en-US" sz="1400" b="1" dirty="0">
                 <a:solidFill>
                   <a:srgbClr val="D7ECE9"/>
                 </a:solidFill>
@@ -2330,7 +2330,7 @@
               </a:rPr>
               <a:t>24.5M</a:t>
             </a:r>
-            <a:endParaRPr lang="en-US" sz="1300" dirty="0"/>
+            <a:endParaRPr lang="en-US" sz="1400" dirty="0"/>
           </a:p>
         </p:txBody>
       </p:sp>
@@ -2440,7 +2440,7 @@
               <a:buNone/>
             </a:pPr>
             <a:r>
-              <a:rPr lang="en-US" sz="1300" b="1" dirty="0">
+              <a:rPr lang="en-US" sz="1400" b="1" dirty="0">
                 <a:solidFill>
                   <a:srgbClr val="F6E7D2"/>
                 </a:solidFill>
@@ -2464,7 +2464,7 @@
               </a:rPr>
               <a:t>~15M</a:t>
             </a:r>
-            <a:endParaRPr lang="en-US" sz="1300" dirty="0"/>
+            <a:endParaRPr lang="en-US" sz="1400" dirty="0"/>
           </a:p>
         </p:txBody>
       </p:sp>
@@ -13900,7 +13900,7 @@
         <p:spPr>
           <a:xfrm>
             <a:off x="1069848" y="5157216"/>
-            <a:ext cx="2911754" cy="310896"/>
+            <a:ext cx="2911754" cy="365760"/>
           </a:xfrm>
           <a:prstGeom prst="rect">
             <a:avLst/>
@@ -13914,12 +13914,12 @@
           <a:p>
             <a:pPr indent="0" marL="0">
               <a:lnSpc>
-                <a:spcPct val="102000"/>
+                <a:spcPct val="100000"/>
               </a:lnSpc>
               <a:buNone/>
             </a:pPr>
             <a:r>
-              <a:rPr lang="en-US" sz="1300" b="1" dirty="0">
+              <a:rPr lang="en-US" sz="1400" b="1" dirty="0">
                 <a:solidFill>
                   <a:srgbClr val="16233F"/>
                 </a:solidFill>
@@ -13929,7 +13929,7 @@
               </a:rPr>
               <a:t>Recoverability preview</a:t>
             </a:r>
-            <a:endParaRPr lang="en-US" sz="1300" dirty="0"/>
+            <a:endParaRPr lang="en-US" sz="1400" dirty="0"/>
           </a:p>
         </p:txBody>
       </p:sp>
@@ -14050,7 +14050,7 @@
         <p:spPr>
           <a:xfrm>
             <a:off x="4859426" y="5157216"/>
-            <a:ext cx="2911754" cy="310896"/>
+            <a:ext cx="2911754" cy="365760"/>
           </a:xfrm>
           <a:prstGeom prst="rect">
             <a:avLst/>
@@ -14064,12 +14064,12 @@
           <a:p>
             <a:pPr indent="0" marL="0">
               <a:lnSpc>
-                <a:spcPct val="102000"/>
+                <a:spcPct val="100000"/>
               </a:lnSpc>
               <a:buNone/>
             </a:pPr>
             <a:r>
-              <a:rPr lang="en-US" sz="1300" b="1" dirty="0">
+              <a:rPr lang="en-US" sz="1400" b="1" dirty="0">
                 <a:solidFill>
                   <a:srgbClr val="16233F"/>
                 </a:solidFill>
@@ -14079,7 +14079,7 @@
               </a:rPr>
               <a:t>Worth-it proof at current price</a:t>
             </a:r>
-            <a:endParaRPr lang="en-US" sz="1300" dirty="0"/>
+            <a:endParaRPr lang="en-US" sz="1400" dirty="0"/>
           </a:p>
         </p:txBody>
       </p:sp>
@@ -14200,7 +14200,7 @@
         <p:spPr>
           <a:xfrm>
             <a:off x="8649005" y="5157216"/>
-            <a:ext cx="2911754" cy="310896"/>
+            <a:ext cx="2911754" cy="365760"/>
           </a:xfrm>
           <a:prstGeom prst="rect">
             <a:avLst/>
@@ -14214,12 +14214,12 @@
           <a:p>
             <a:pPr indent="0" marL="0">
               <a:lnSpc>
-                <a:spcPct val="102000"/>
+                <a:spcPct val="100000"/>
               </a:lnSpc>
               <a:buNone/>
             </a:pPr>
             <a:r>
-              <a:rPr lang="en-US" sz="1300" b="1" dirty="0">
+              <a:rPr lang="en-US" sz="1400" b="1" dirty="0">
                 <a:solidFill>
                   <a:srgbClr val="16233F"/>
                 </a:solidFill>
@@ -14229,7 +14229,7 @@
               </a:rPr>
               <a:t>Delivery date on SKU</a:t>
             </a:r>
-            <a:endParaRPr lang="en-US" sz="1300" dirty="0"/>
+            <a:endParaRPr lang="en-US" sz="1400" dirty="0"/>
           </a:p>
         </p:txBody>
       </p:sp>
@@ -17021,7 +17021,7 @@
               <a:buNone/>
             </a:pPr>
             <a:r>
-              <a:rPr lang="en-US" sz="1300" b="1" dirty="0">
+              <a:rPr lang="en-US" sz="1400" b="1" dirty="0">
                 <a:solidFill>
                   <a:srgbClr val="FFFFFF"/>
                 </a:solidFill>
@@ -17031,7 +17031,7 @@
               </a:rPr>
               <a:t>Primary: resolved ÷ (resolved + still-cold)</a:t>
             </a:r>
-            <a:endParaRPr lang="en-US" sz="1300" dirty="0"/>
+            <a:endParaRPr lang="en-US" sz="1400" dirty="0"/>
           </a:p>
         </p:txBody>
       </p:sp>

</xml_diff>